<commit_message>
Sync the promise presentation with the promise resolution branch
The deck reports the results of research/promise-resolution: all 888
pipeline cases meet their expected outcome, and the generic forms not yet
supported are recorded gaps. The slides, narration, video, PDF, Keynote
and PowerPoint outputs are regenerated.

Co-Authored-By: Claude Opus 5.5 <noreply@anthropic.com>
</commit_message>
<xml_diff>
--- a/research/presentation/out/slides.pptx
+++ b/research/presentation/out/slides.pptx
@@ -534,7 +534,7 @@
           <a:p>
             <a:pPr/>
             <a:r>
-              <a:t>This deck summarises research/promise-normalization.md and research/promise-coverage-audit.md. Nothing in it is implemented; laws are argued, not mechanized.</a:t>
+              <a:t>This deck accompanies the promise-resolution pull request and summarises research/promise-normalization.md and research/promise-coverage-audit.md. The native contracts and the generic descriptors are implemented and checked in Lean; the generic forms not yet supported are recorded as gaps.</a:t>
             </a:r>
           </a:p>
         </p:txBody>
@@ -674,7 +674,7 @@
           <a:p>
             <a:pPr/>
             <a:r>
-              <a:t>Status as the implementation reports it, not yet committed. The associated-result case verifies end to end. The generic wrap with return await still waits for await and return inside generic bodies. All refused programs are refused; eight negative cases are refused earlier than their intended obligation or with a different message, which the remaining work settles.</a:t>
+              <a:t>The associated-result case and the number-bounded wrap verify end to end. The generic wrap with return await and back are recorded gaps. Every unsafe program is refused; eight negative cases are refused before their intended check, and are recorded as gaps too.</a:t>
             </a:r>
           </a:p>
         </p:txBody>
@@ -744,7 +744,7 @@
           <a:p>
             <a:pPr/>
             <a:r>
-              <a:t>Before: skjs-coverage.json on verification/graph-core. The array unit verifies in the implementation's stable-await case. A full census rerun follows the commit.</a:t>
+              <a:t>Before: skjs-coverage.json on verification/graph-core. The array unit verifies in the implementation's stable-await case. The census has not been rerun.</a:t>
             </a:r>
           </a:p>
         </p:txBody>
@@ -1304,7 +1304,7 @@
           <a:p>
             <a:pPr/>
             <a:r>
-              <a:t>This is the meaning of a qualified scheme in codex's semantics (descriptorDomain in ResolutionDescriptors.lean): the scheme's reassignments are restricted to coherent descriptor tuples. A call supplies one such tuple, a descriptor. The relations are fixed outside the recursive type graph.</a:t>
+              <a:t>This is the meaning of a qualified scheme in the implementation (descriptorDomain in ResolutionDescriptors.lean): the scheme's reassignments are restricted to coherent descriptor tuples. A call supplies one such tuple, a descriptor. The relations are fixed outside the recursive type graph.</a:t>
             </a:r>
           </a:p>
         </p:txBody>

</xml_diff>

<commit_message>
Present Awaited<T> as an implied bound on T
Slides 9 and 10 now show the constraint in T's declared type: Awaited<T>
in a signature implies T : Resolvable, whose classification fixes the
associated types T.Observed and T.Result. The rules slide reads as who
fixes them (the producer proposes a classification, Lean checks it), and
the comparison and limits slides use the same notation. Narration and
outputs are regenerated.

Co-Authored-By: Claude Opus 5.5 <noreply@anthropic.com>
</commit_message>
<xml_diff>
--- a/research/presentation/out/slides.pptx
+++ b/research/presentation/out/slides.pptx
@@ -1304,7 +1304,7 @@
           <a:p>
             <a:pPr/>
             <a:r>
-              <a:t>This is the meaning of a qualified scheme in the implementation (descriptorDomain in ResolutionDescriptors.lean): the scheme's reassignments are restricted to coherent descriptor tuples. A call supplies one such tuple, a descriptor. The relations are fixed outside the recursive type graph.</a:t>
+              <a:t>The elaborated signature is notation for what the implementation records: a type parameter with resolution slots (the fragment's resolution field, a resolution descriptor in the request). The implied-bounds rules are stated in SOURCE-CONTRACTS.md, section Implied bounds.</a:t>
             </a:r>
           </a:p>
         </p:txBody>
@@ -1374,7 +1374,7 @@
           <a:p>
             <a:pPr/>
             <a:r>
-              <a:t>These are the inductive relations Resolves and Observes in ResolutionCapabilities.lean. A type with no derivation, such as an open record, has no descriptor, so a generic instantiation at it is refused.</a:t>
+              <a:t>These are the inductive relations Resolves and Observes in ResolutionCapabilities.lean, read as computing the associated types. A type with no classification, such as an open record, makes the call refused.</a:t>
             </a:r>
           </a:p>
         </p:txBody>

</xml_diff>

<commit_message>
Present awaitable and resolvable qualifications and the final results
The rules slide has the stable, native and union rules, the exactness
lemma, and proof search in Lean as what classifies a call. The implied
bounds slide adds T extends Awaitable and T extends Resolvable with the
qualified intrinsics. Targets, census and limits give 903 cases, 2,467
of 2,674 units with no unit moved by this branch, and the remaining
limits. Slides, narration, video, PDF, pptx and Keynote are regenerated.

Co-Authored-By: Claude Opus 5.5 <noreply@anthropic.com>
</commit_message>
<xml_diff>
--- a/research/presentation/out/slides.pptx
+++ b/research/presentation/out/slides.pptx
@@ -76,9 +76,9 @@
         </a:solidFill>
         <a:effectLst/>
         <a:uFillTx/>
-        <a:latin typeface="+mj-lt"/>
-        <a:ea typeface="+mj-ea"/>
-        <a:cs typeface="+mj-cs"/>
+        <a:latin typeface="+mn-lt"/>
+        <a:ea typeface="+mn-ea"/>
+        <a:cs typeface="+mn-cs"/>
         <a:sym typeface="Calibri"/>
       </a:defRPr>
     </a:lvl1pPr>
@@ -106,9 +106,9 @@
         </a:solidFill>
         <a:effectLst/>
         <a:uFillTx/>
-        <a:latin typeface="+mj-lt"/>
-        <a:ea typeface="+mj-ea"/>
-        <a:cs typeface="+mj-cs"/>
+        <a:latin typeface="+mn-lt"/>
+        <a:ea typeface="+mn-ea"/>
+        <a:cs typeface="+mn-cs"/>
         <a:sym typeface="Calibri"/>
       </a:defRPr>
     </a:lvl2pPr>
@@ -136,9 +136,9 @@
         </a:solidFill>
         <a:effectLst/>
         <a:uFillTx/>
-        <a:latin typeface="+mj-lt"/>
-        <a:ea typeface="+mj-ea"/>
-        <a:cs typeface="+mj-cs"/>
+        <a:latin typeface="+mn-lt"/>
+        <a:ea typeface="+mn-ea"/>
+        <a:cs typeface="+mn-cs"/>
         <a:sym typeface="Calibri"/>
       </a:defRPr>
     </a:lvl3pPr>
@@ -166,9 +166,9 @@
         </a:solidFill>
         <a:effectLst/>
         <a:uFillTx/>
-        <a:latin typeface="+mj-lt"/>
-        <a:ea typeface="+mj-ea"/>
-        <a:cs typeface="+mj-cs"/>
+        <a:latin typeface="+mn-lt"/>
+        <a:ea typeface="+mn-ea"/>
+        <a:cs typeface="+mn-cs"/>
         <a:sym typeface="Calibri"/>
       </a:defRPr>
     </a:lvl4pPr>
@@ -196,9 +196,9 @@
         </a:solidFill>
         <a:effectLst/>
         <a:uFillTx/>
-        <a:latin typeface="+mj-lt"/>
-        <a:ea typeface="+mj-ea"/>
-        <a:cs typeface="+mj-cs"/>
+        <a:latin typeface="+mn-lt"/>
+        <a:ea typeface="+mn-ea"/>
+        <a:cs typeface="+mn-cs"/>
         <a:sym typeface="Calibri"/>
       </a:defRPr>
     </a:lvl5pPr>
@@ -226,9 +226,9 @@
         </a:solidFill>
         <a:effectLst/>
         <a:uFillTx/>
-        <a:latin typeface="+mj-lt"/>
-        <a:ea typeface="+mj-ea"/>
-        <a:cs typeface="+mj-cs"/>
+        <a:latin typeface="+mn-lt"/>
+        <a:ea typeface="+mn-ea"/>
+        <a:cs typeface="+mn-cs"/>
         <a:sym typeface="Calibri"/>
       </a:defRPr>
     </a:lvl6pPr>
@@ -256,9 +256,9 @@
         </a:solidFill>
         <a:effectLst/>
         <a:uFillTx/>
-        <a:latin typeface="+mj-lt"/>
-        <a:ea typeface="+mj-ea"/>
-        <a:cs typeface="+mj-cs"/>
+        <a:latin typeface="+mn-lt"/>
+        <a:ea typeface="+mn-ea"/>
+        <a:cs typeface="+mn-cs"/>
         <a:sym typeface="Calibri"/>
       </a:defRPr>
     </a:lvl7pPr>
@@ -286,9 +286,9 @@
         </a:solidFill>
         <a:effectLst/>
         <a:uFillTx/>
-        <a:latin typeface="+mj-lt"/>
-        <a:ea typeface="+mj-ea"/>
-        <a:cs typeface="+mj-cs"/>
+        <a:latin typeface="+mn-lt"/>
+        <a:ea typeface="+mn-ea"/>
+        <a:cs typeface="+mn-cs"/>
         <a:sym typeface="Calibri"/>
       </a:defRPr>
     </a:lvl8pPr>
@@ -316,9 +316,9 @@
         </a:solidFill>
         <a:effectLst/>
         <a:uFillTx/>
-        <a:latin typeface="+mj-lt"/>
-        <a:ea typeface="+mj-ea"/>
-        <a:cs typeface="+mj-cs"/>
+        <a:latin typeface="+mn-lt"/>
+        <a:ea typeface="+mn-ea"/>
+        <a:cs typeface="+mn-cs"/>
         <a:sym typeface="Calibri"/>
       </a:defRPr>
     </a:lvl9pPr>
@@ -403,73 +403,73 @@
   <p:notesStyle>
     <a:lvl1pPr defTabSz="457200" latinLnBrk="0">
       <a:defRPr sz="1200">
-        <a:latin typeface="+mj-lt"/>
-        <a:ea typeface="+mj-ea"/>
-        <a:cs typeface="+mj-cs"/>
+        <a:latin typeface="+mn-lt"/>
+        <a:ea typeface="+mn-ea"/>
+        <a:cs typeface="+mn-cs"/>
         <a:sym typeface="Calibri"/>
       </a:defRPr>
     </a:lvl1pPr>
     <a:lvl2pPr indent="228600" defTabSz="457200" latinLnBrk="0">
       <a:defRPr sz="1200">
-        <a:latin typeface="+mj-lt"/>
-        <a:ea typeface="+mj-ea"/>
-        <a:cs typeface="+mj-cs"/>
+        <a:latin typeface="+mn-lt"/>
+        <a:ea typeface="+mn-ea"/>
+        <a:cs typeface="+mn-cs"/>
         <a:sym typeface="Calibri"/>
       </a:defRPr>
     </a:lvl2pPr>
     <a:lvl3pPr indent="457200" defTabSz="457200" latinLnBrk="0">
       <a:defRPr sz="1200">
-        <a:latin typeface="+mj-lt"/>
-        <a:ea typeface="+mj-ea"/>
-        <a:cs typeface="+mj-cs"/>
+        <a:latin typeface="+mn-lt"/>
+        <a:ea typeface="+mn-ea"/>
+        <a:cs typeface="+mn-cs"/>
         <a:sym typeface="Calibri"/>
       </a:defRPr>
     </a:lvl3pPr>
     <a:lvl4pPr indent="685800" defTabSz="457200" latinLnBrk="0">
       <a:defRPr sz="1200">
-        <a:latin typeface="+mj-lt"/>
-        <a:ea typeface="+mj-ea"/>
-        <a:cs typeface="+mj-cs"/>
+        <a:latin typeface="+mn-lt"/>
+        <a:ea typeface="+mn-ea"/>
+        <a:cs typeface="+mn-cs"/>
         <a:sym typeface="Calibri"/>
       </a:defRPr>
     </a:lvl4pPr>
     <a:lvl5pPr indent="914400" defTabSz="457200" latinLnBrk="0">
       <a:defRPr sz="1200">
-        <a:latin typeface="+mj-lt"/>
-        <a:ea typeface="+mj-ea"/>
-        <a:cs typeface="+mj-cs"/>
+        <a:latin typeface="+mn-lt"/>
+        <a:ea typeface="+mn-ea"/>
+        <a:cs typeface="+mn-cs"/>
         <a:sym typeface="Calibri"/>
       </a:defRPr>
     </a:lvl5pPr>
     <a:lvl6pPr indent="1143000" defTabSz="457200" latinLnBrk="0">
       <a:defRPr sz="1200">
-        <a:latin typeface="+mj-lt"/>
-        <a:ea typeface="+mj-ea"/>
-        <a:cs typeface="+mj-cs"/>
+        <a:latin typeface="+mn-lt"/>
+        <a:ea typeface="+mn-ea"/>
+        <a:cs typeface="+mn-cs"/>
         <a:sym typeface="Calibri"/>
       </a:defRPr>
     </a:lvl6pPr>
     <a:lvl7pPr indent="1371600" defTabSz="457200" latinLnBrk="0">
       <a:defRPr sz="1200">
-        <a:latin typeface="+mj-lt"/>
-        <a:ea typeface="+mj-ea"/>
-        <a:cs typeface="+mj-cs"/>
+        <a:latin typeface="+mn-lt"/>
+        <a:ea typeface="+mn-ea"/>
+        <a:cs typeface="+mn-cs"/>
         <a:sym typeface="Calibri"/>
       </a:defRPr>
     </a:lvl7pPr>
     <a:lvl8pPr indent="1600200" defTabSz="457200" latinLnBrk="0">
       <a:defRPr sz="1200">
-        <a:latin typeface="+mj-lt"/>
-        <a:ea typeface="+mj-ea"/>
-        <a:cs typeface="+mj-cs"/>
+        <a:latin typeface="+mn-lt"/>
+        <a:ea typeface="+mn-ea"/>
+        <a:cs typeface="+mn-cs"/>
         <a:sym typeface="Calibri"/>
       </a:defRPr>
     </a:lvl8pPr>
     <a:lvl9pPr indent="1828800" defTabSz="457200" latinLnBrk="0">
       <a:defRPr sz="1200">
-        <a:latin typeface="+mj-lt"/>
-        <a:ea typeface="+mj-ea"/>
-        <a:cs typeface="+mj-cs"/>
+        <a:latin typeface="+mn-lt"/>
+        <a:ea typeface="+mn-ea"/>
+        <a:cs typeface="+mn-cs"/>
         <a:sym typeface="Calibri"/>
       </a:defRPr>
     </a:lvl9pPr>
@@ -604,7 +604,7 @@
           <a:p>
             <a:pPr/>
             <a:r>
-              <a:t>Derived from the classification rules on the previous slide. The open record is exactly where TypeScript's Awaited is unsound; PromiseLike needs a rule for typed thenables, which neither design has.</a:t>
+              <a:t>Derived from the classification rules on the previous slide. The open record is exactly where TypeScript's Awaited is unsound; Awaiting a PromiseLike would adopt its then, which this design refuses on principle.</a:t>
             </a:r>
           </a:p>
         </p:txBody>
@@ -674,7 +674,7 @@
           <a:p>
             <a:pPr/>
             <a:r>
-              <a:t>The associated-result case and the number-bounded wrap verify end to end. The generic wrap with return await and back are recorded gaps. Every unsafe program is refused; eight negative cases are refused before their intended check, and are recorded as gaps too.</a:t>
+              <a:t>Each program is a pipeline case. The open record, the erasure and the 42 case are negative cases refused at their own obligations. The five gaps are refused before their intended check: generic function types, an ambient Awaited&lt;T&gt;, mutable associated-result storage and an unknown generic result.</a:t>
             </a:r>
           </a:p>
         </p:txBody>
@@ -744,7 +744,7 @@
           <a:p>
             <a:pPr/>
             <a:r>
-              <a:t>Before: skjs-coverage.json on verification/graph-core. The array unit verifies in the implementation's stable-await case. The census has not been rerun.</a:t>
+              <a:t>Both censuses are full runs with SKJS confirmation. Thenable adoption: awaiting a PromiseLike, or returning a fresh object from an async function, makes JavaScript call a then the type does not describe. keyof Promise&lt;number&gt; contains a unique symbol.</a:t>
             </a:r>
           </a:p>
         </p:txBody>
@@ -814,7 +814,7 @@
           <a:p>
             <a:pPr/>
             <a:r>
-              <a:t>The non-uniqueness comes from the narrow rule: number is below number | string, which resolves to itself. Only programs that need Awaited&lt;T&gt; to be at most a specific type are affected. The further rules are described in research/promise-coverage-audit.md.</a:t>
+              <a:t>The higher-order gaps are generic-promise-result-widening and invalid-generic-promise-erasure. The further rules are described in research/promise-coverage-audit.md.</a:t>
             </a:r>
           </a:p>
         </p:txBody>
@@ -1304,7 +1304,7 @@
           <a:p>
             <a:pPr/>
             <a:r>
-              <a:t>The elaborated signature is notation for what the implementation records: a type parameter with resolution slots (the fragment's resolution field, a resolution descriptor in the request). The implied-bounds rules are stated in SOURCE-CONTRACTS.md, section Implied bounds.</a:t>
+              <a:t>Awaitable and Resolvable are the verifier's own declarations, both unknown as types, in tools/resolvable.d.ts; the parser recognizes each by its declaration. Every resolvable type is awaitable. %PromiseResolve% : ∀X : Awaitable. (X) ⇒ Promise&lt;X.Observed&gt;. The implied-bounds rules are stated in SOURCE-CONTRACTS.md, section Implied bounds.</a:t>
             </a:r>
           </a:p>
         </p:txBody>
@@ -1374,7 +1374,7 @@
           <a:p>
             <a:pPr/>
             <a:r>
-              <a:t>These are the inductive relations Resolves and Observes in ResolutionCapabilities.lean, read as computing the associated types. A type with no classification, such as an open record, makes the call refused.</a:t>
+              <a:t>These are the inductive relations Observes and Resolves in ResolutionCapabilities.lean; the exactness lemmas are Observes.exact and Resolves.exact. A native promise is observable at any payload; its result needs the payload's result. A type with no classification, such as an open record, makes a call that needs its result refused.</a:t>
             </a:r>
           </a:p>
         </p:txBody>
@@ -2952,9 +2952,9 @@
             <a:srgbClr val="000000"/>
           </a:solidFill>
           <a:uFillTx/>
-          <a:latin typeface="+mj-lt"/>
-          <a:ea typeface="+mj-ea"/>
-          <a:cs typeface="+mj-cs"/>
+          <a:latin typeface="+mn-lt"/>
+          <a:ea typeface="+mn-ea"/>
+          <a:cs typeface="+mn-cs"/>
           <a:sym typeface="Calibri"/>
         </a:defRPr>
       </a:lvl1pPr>
@@ -2978,9 +2978,9 @@
             <a:srgbClr val="000000"/>
           </a:solidFill>
           <a:uFillTx/>
-          <a:latin typeface="+mj-lt"/>
-          <a:ea typeface="+mj-ea"/>
-          <a:cs typeface="+mj-cs"/>
+          <a:latin typeface="+mn-lt"/>
+          <a:ea typeface="+mn-ea"/>
+          <a:cs typeface="+mn-cs"/>
           <a:sym typeface="Calibri"/>
         </a:defRPr>
       </a:lvl2pPr>
@@ -3004,9 +3004,9 @@
             <a:srgbClr val="000000"/>
           </a:solidFill>
           <a:uFillTx/>
-          <a:latin typeface="+mj-lt"/>
-          <a:ea typeface="+mj-ea"/>
-          <a:cs typeface="+mj-cs"/>
+          <a:latin typeface="+mn-lt"/>
+          <a:ea typeface="+mn-ea"/>
+          <a:cs typeface="+mn-cs"/>
           <a:sym typeface="Calibri"/>
         </a:defRPr>
       </a:lvl3pPr>
@@ -3030,9 +3030,9 @@
             <a:srgbClr val="000000"/>
           </a:solidFill>
           <a:uFillTx/>
-          <a:latin typeface="+mj-lt"/>
-          <a:ea typeface="+mj-ea"/>
-          <a:cs typeface="+mj-cs"/>
+          <a:latin typeface="+mn-lt"/>
+          <a:ea typeface="+mn-ea"/>
+          <a:cs typeface="+mn-cs"/>
           <a:sym typeface="Calibri"/>
         </a:defRPr>
       </a:lvl4pPr>
@@ -3056,9 +3056,9 @@
             <a:srgbClr val="000000"/>
           </a:solidFill>
           <a:uFillTx/>
-          <a:latin typeface="+mj-lt"/>
-          <a:ea typeface="+mj-ea"/>
-          <a:cs typeface="+mj-cs"/>
+          <a:latin typeface="+mn-lt"/>
+          <a:ea typeface="+mn-ea"/>
+          <a:cs typeface="+mn-cs"/>
           <a:sym typeface="Calibri"/>
         </a:defRPr>
       </a:lvl5pPr>
@@ -3082,9 +3082,9 @@
             <a:srgbClr val="000000"/>
           </a:solidFill>
           <a:uFillTx/>
-          <a:latin typeface="+mj-lt"/>
-          <a:ea typeface="+mj-ea"/>
-          <a:cs typeface="+mj-cs"/>
+          <a:latin typeface="+mn-lt"/>
+          <a:ea typeface="+mn-ea"/>
+          <a:cs typeface="+mn-cs"/>
           <a:sym typeface="Calibri"/>
         </a:defRPr>
       </a:lvl6pPr>
@@ -3108,9 +3108,9 @@
             <a:srgbClr val="000000"/>
           </a:solidFill>
           <a:uFillTx/>
-          <a:latin typeface="+mj-lt"/>
-          <a:ea typeface="+mj-ea"/>
-          <a:cs typeface="+mj-cs"/>
+          <a:latin typeface="+mn-lt"/>
+          <a:ea typeface="+mn-ea"/>
+          <a:cs typeface="+mn-cs"/>
           <a:sym typeface="Calibri"/>
         </a:defRPr>
       </a:lvl7pPr>
@@ -3134,9 +3134,9 @@
             <a:srgbClr val="000000"/>
           </a:solidFill>
           <a:uFillTx/>
-          <a:latin typeface="+mj-lt"/>
-          <a:ea typeface="+mj-ea"/>
-          <a:cs typeface="+mj-cs"/>
+          <a:latin typeface="+mn-lt"/>
+          <a:ea typeface="+mn-ea"/>
+          <a:cs typeface="+mn-cs"/>
           <a:sym typeface="Calibri"/>
         </a:defRPr>
       </a:lvl8pPr>
@@ -3160,9 +3160,9 @@
             <a:srgbClr val="000000"/>
           </a:solidFill>
           <a:uFillTx/>
-          <a:latin typeface="+mj-lt"/>
-          <a:ea typeface="+mj-ea"/>
-          <a:cs typeface="+mj-cs"/>
+          <a:latin typeface="+mn-lt"/>
+          <a:ea typeface="+mn-ea"/>
+          <a:cs typeface="+mn-cs"/>
           <a:sym typeface="Calibri"/>
         </a:defRPr>
       </a:lvl9pPr>
@@ -3188,9 +3188,9 @@
             <a:srgbClr val="000000"/>
           </a:solidFill>
           <a:uFillTx/>
-          <a:latin typeface="+mj-lt"/>
-          <a:ea typeface="+mj-ea"/>
-          <a:cs typeface="+mj-cs"/>
+          <a:latin typeface="+mn-lt"/>
+          <a:ea typeface="+mn-ea"/>
+          <a:cs typeface="+mn-cs"/>
           <a:sym typeface="Calibri"/>
         </a:defRPr>
       </a:lvl1pPr>
@@ -3214,9 +3214,9 @@
             <a:srgbClr val="000000"/>
           </a:solidFill>
           <a:uFillTx/>
-          <a:latin typeface="+mj-lt"/>
-          <a:ea typeface="+mj-ea"/>
-          <a:cs typeface="+mj-cs"/>
+          <a:latin typeface="+mn-lt"/>
+          <a:ea typeface="+mn-ea"/>
+          <a:cs typeface="+mn-cs"/>
           <a:sym typeface="Calibri"/>
         </a:defRPr>
       </a:lvl2pPr>
@@ -3240,9 +3240,9 @@
             <a:srgbClr val="000000"/>
           </a:solidFill>
           <a:uFillTx/>
-          <a:latin typeface="+mj-lt"/>
-          <a:ea typeface="+mj-ea"/>
-          <a:cs typeface="+mj-cs"/>
+          <a:latin typeface="+mn-lt"/>
+          <a:ea typeface="+mn-ea"/>
+          <a:cs typeface="+mn-cs"/>
           <a:sym typeface="Calibri"/>
         </a:defRPr>
       </a:lvl3pPr>
@@ -3266,9 +3266,9 @@
             <a:srgbClr val="000000"/>
           </a:solidFill>
           <a:uFillTx/>
-          <a:latin typeface="+mj-lt"/>
-          <a:ea typeface="+mj-ea"/>
-          <a:cs typeface="+mj-cs"/>
+          <a:latin typeface="+mn-lt"/>
+          <a:ea typeface="+mn-ea"/>
+          <a:cs typeface="+mn-cs"/>
           <a:sym typeface="Calibri"/>
         </a:defRPr>
       </a:lvl4pPr>
@@ -3292,9 +3292,9 @@
             <a:srgbClr val="000000"/>
           </a:solidFill>
           <a:uFillTx/>
-          <a:latin typeface="+mj-lt"/>
-          <a:ea typeface="+mj-ea"/>
-          <a:cs typeface="+mj-cs"/>
+          <a:latin typeface="+mn-lt"/>
+          <a:ea typeface="+mn-ea"/>
+          <a:cs typeface="+mn-cs"/>
           <a:sym typeface="Calibri"/>
         </a:defRPr>
       </a:lvl5pPr>
@@ -3318,9 +3318,9 @@
             <a:srgbClr val="000000"/>
           </a:solidFill>
           <a:uFillTx/>
-          <a:latin typeface="+mj-lt"/>
-          <a:ea typeface="+mj-ea"/>
-          <a:cs typeface="+mj-cs"/>
+          <a:latin typeface="+mn-lt"/>
+          <a:ea typeface="+mn-ea"/>
+          <a:cs typeface="+mn-cs"/>
           <a:sym typeface="Calibri"/>
         </a:defRPr>
       </a:lvl6pPr>
@@ -3344,9 +3344,9 @@
             <a:srgbClr val="000000"/>
           </a:solidFill>
           <a:uFillTx/>
-          <a:latin typeface="+mj-lt"/>
-          <a:ea typeface="+mj-ea"/>
-          <a:cs typeface="+mj-cs"/>
+          <a:latin typeface="+mn-lt"/>
+          <a:ea typeface="+mn-ea"/>
+          <a:cs typeface="+mn-cs"/>
           <a:sym typeface="Calibri"/>
         </a:defRPr>
       </a:lvl7pPr>
@@ -3370,9 +3370,9 @@
             <a:srgbClr val="000000"/>
           </a:solidFill>
           <a:uFillTx/>
-          <a:latin typeface="+mj-lt"/>
-          <a:ea typeface="+mj-ea"/>
-          <a:cs typeface="+mj-cs"/>
+          <a:latin typeface="+mn-lt"/>
+          <a:ea typeface="+mn-ea"/>
+          <a:cs typeface="+mn-cs"/>
           <a:sym typeface="Calibri"/>
         </a:defRPr>
       </a:lvl8pPr>
@@ -3396,9 +3396,9 @@
             <a:srgbClr val="000000"/>
           </a:solidFill>
           <a:uFillTx/>
-          <a:latin typeface="+mj-lt"/>
-          <a:ea typeface="+mj-ea"/>
-          <a:cs typeface="+mj-cs"/>
+          <a:latin typeface="+mn-lt"/>
+          <a:ea typeface="+mn-ea"/>
+          <a:cs typeface="+mn-cs"/>
           <a:sym typeface="Calibri"/>
         </a:defRPr>
       </a:lvl9pPr>
@@ -4456,14 +4456,14 @@
     </a:clrScheme>
     <a:fontScheme name="Office Theme">
       <a:majorFont>
+        <a:latin typeface="Helvetica"/>
+        <a:ea typeface="Helvetica"/>
+        <a:cs typeface="Helvetica"/>
+      </a:majorFont>
+      <a:minorFont>
         <a:latin typeface="Calibri"/>
         <a:ea typeface="Calibri"/>
         <a:cs typeface="Calibri"/>
-      </a:majorFont>
-      <a:minorFont>
-        <a:latin typeface="Helvetica"/>
-        <a:ea typeface="Helvetica"/>
-        <a:cs typeface="Helvetica"/>
       </a:minorFont>
     </a:fontScheme>
     <a:fmtScheme name="Office Theme">
@@ -4668,9 +4668,9 @@
             </a:solidFill>
             <a:effectLst/>
             <a:uFillTx/>
-            <a:latin typeface="+mj-lt"/>
-            <a:ea typeface="+mj-ea"/>
-            <a:cs typeface="+mj-cs"/>
+            <a:latin typeface="+mn-lt"/>
+            <a:ea typeface="+mn-ea"/>
+            <a:cs typeface="+mn-cs"/>
             <a:sym typeface="Calibri"/>
           </a:defRPr>
         </a:defPPr>
@@ -5245,9 +5245,9 @@
             </a:solidFill>
             <a:effectLst/>
             <a:uFillTx/>
-            <a:latin typeface="+mj-lt"/>
-            <a:ea typeface="+mj-ea"/>
-            <a:cs typeface="+mj-cs"/>
+            <a:latin typeface="+mn-lt"/>
+            <a:ea typeface="+mn-ea"/>
+            <a:cs typeface="+mn-cs"/>
             <a:sym typeface="Calibri"/>
           </a:defRPr>
         </a:defPPr>
@@ -5540,14 +5540,14 @@
     </a:clrScheme>
     <a:fontScheme name="Office Theme">
       <a:majorFont>
+        <a:latin typeface="Helvetica"/>
+        <a:ea typeface="Helvetica"/>
+        <a:cs typeface="Helvetica"/>
+      </a:majorFont>
+      <a:minorFont>
         <a:latin typeface="Calibri"/>
         <a:ea typeface="Calibri"/>
         <a:cs typeface="Calibri"/>
-      </a:majorFont>
-      <a:minorFont>
-        <a:latin typeface="Helvetica"/>
-        <a:ea typeface="Helvetica"/>
-        <a:cs typeface="Helvetica"/>
       </a:minorFont>
     </a:fontScheme>
     <a:fmtScheme name="Office Theme">
@@ -5752,9 +5752,9 @@
             </a:solidFill>
             <a:effectLst/>
             <a:uFillTx/>
-            <a:latin typeface="+mj-lt"/>
-            <a:ea typeface="+mj-ea"/>
-            <a:cs typeface="+mj-cs"/>
+            <a:latin typeface="+mn-lt"/>
+            <a:ea typeface="+mn-ea"/>
+            <a:cs typeface="+mn-cs"/>
             <a:sym typeface="Calibri"/>
           </a:defRPr>
         </a:defPPr>
@@ -6329,9 +6329,9 @@
             </a:solidFill>
             <a:effectLst/>
             <a:uFillTx/>
-            <a:latin typeface="+mj-lt"/>
-            <a:ea typeface="+mj-ea"/>
-            <a:cs typeface="+mj-cs"/>
+            <a:latin typeface="+mn-lt"/>
+            <a:ea typeface="+mn-ea"/>
+            <a:cs typeface="+mn-cs"/>
             <a:sym typeface="Calibri"/>
           </a:defRPr>
         </a:defPPr>

</xml_diff>